<commit_message>
Adding image to presentation notebook. Updated power point source for the images
</commit_message>
<xml_diff>
--- a/project/plots/autoencoder_compression.pptx
+++ b/project/plots/autoencoder_compression.pptx
@@ -6,6 +6,7 @@
   </p:sldMasterIdLst>
   <p:sldIdLst>
     <p:sldId id="256" r:id="rId2"/>
+    <p:sldId id="257" r:id="rId3"/>
   </p:sldIdLst>
   <p:sldSz cx="12192000" cy="6858000"/>
   <p:notesSz cx="6858000" cy="9144000"/>
@@ -104,6 +105,11 @@
       </a:defRPr>
     </a:lvl9pPr>
   </p:defaultTextStyle>
+  <p:extLst>
+    <p:ext uri="{EFAFB233-063F-42B5-8137-9DF3F51BA10A}">
+      <p15:sldGuideLst xmlns:p15="http://schemas.microsoft.com/office/powerpoint/2012/main"/>
+    </p:ext>
+  </p:extLst>
 </p:presentation>
 </file>
 
@@ -256,7 +262,7 @@
           <a:p>
             <a:fld id="{23DBF8B2-B501-47AE-9400-A1F93D77FDE3}" type="datetimeFigureOut">
               <a:rPr lang="en-SE" smtClean="0"/>
-              <a:t>2025-12-08</a:t>
+              <a:t>2025-12-12</a:t>
             </a:fld>
             <a:endParaRPr lang="en-SE"/>
           </a:p>
@@ -456,7 +462,7 @@
           <a:p>
             <a:fld id="{23DBF8B2-B501-47AE-9400-A1F93D77FDE3}" type="datetimeFigureOut">
               <a:rPr lang="en-SE" smtClean="0"/>
-              <a:t>2025-12-08</a:t>
+              <a:t>2025-12-12</a:t>
             </a:fld>
             <a:endParaRPr lang="en-SE"/>
           </a:p>
@@ -666,7 +672,7 @@
           <a:p>
             <a:fld id="{23DBF8B2-B501-47AE-9400-A1F93D77FDE3}" type="datetimeFigureOut">
               <a:rPr lang="en-SE" smtClean="0"/>
-              <a:t>2025-12-08</a:t>
+              <a:t>2025-12-12</a:t>
             </a:fld>
             <a:endParaRPr lang="en-SE"/>
           </a:p>
@@ -866,7 +872,7 @@
           <a:p>
             <a:fld id="{23DBF8B2-B501-47AE-9400-A1F93D77FDE3}" type="datetimeFigureOut">
               <a:rPr lang="en-SE" smtClean="0"/>
-              <a:t>2025-12-08</a:t>
+              <a:t>2025-12-12</a:t>
             </a:fld>
             <a:endParaRPr lang="en-SE"/>
           </a:p>
@@ -1142,7 +1148,7 @@
           <a:p>
             <a:fld id="{23DBF8B2-B501-47AE-9400-A1F93D77FDE3}" type="datetimeFigureOut">
               <a:rPr lang="en-SE" smtClean="0"/>
-              <a:t>2025-12-08</a:t>
+              <a:t>2025-12-12</a:t>
             </a:fld>
             <a:endParaRPr lang="en-SE"/>
           </a:p>
@@ -1410,7 +1416,7 @@
           <a:p>
             <a:fld id="{23DBF8B2-B501-47AE-9400-A1F93D77FDE3}" type="datetimeFigureOut">
               <a:rPr lang="en-SE" smtClean="0"/>
-              <a:t>2025-12-08</a:t>
+              <a:t>2025-12-12</a:t>
             </a:fld>
             <a:endParaRPr lang="en-SE"/>
           </a:p>
@@ -1825,7 +1831,7 @@
           <a:p>
             <a:fld id="{23DBF8B2-B501-47AE-9400-A1F93D77FDE3}" type="datetimeFigureOut">
               <a:rPr lang="en-SE" smtClean="0"/>
-              <a:t>2025-12-08</a:t>
+              <a:t>2025-12-12</a:t>
             </a:fld>
             <a:endParaRPr lang="en-SE"/>
           </a:p>
@@ -1967,7 +1973,7 @@
           <a:p>
             <a:fld id="{23DBF8B2-B501-47AE-9400-A1F93D77FDE3}" type="datetimeFigureOut">
               <a:rPr lang="en-SE" smtClean="0"/>
-              <a:t>2025-12-08</a:t>
+              <a:t>2025-12-12</a:t>
             </a:fld>
             <a:endParaRPr lang="en-SE"/>
           </a:p>
@@ -2080,7 +2086,7 @@
           <a:p>
             <a:fld id="{23DBF8B2-B501-47AE-9400-A1F93D77FDE3}" type="datetimeFigureOut">
               <a:rPr lang="en-SE" smtClean="0"/>
-              <a:t>2025-12-08</a:t>
+              <a:t>2025-12-12</a:t>
             </a:fld>
             <a:endParaRPr lang="en-SE"/>
           </a:p>
@@ -2393,7 +2399,7 @@
           <a:p>
             <a:fld id="{23DBF8B2-B501-47AE-9400-A1F93D77FDE3}" type="datetimeFigureOut">
               <a:rPr lang="en-SE" smtClean="0"/>
-              <a:t>2025-12-08</a:t>
+              <a:t>2025-12-12</a:t>
             </a:fld>
             <a:endParaRPr lang="en-SE"/>
           </a:p>
@@ -2682,7 +2688,7 @@
           <a:p>
             <a:fld id="{23DBF8B2-B501-47AE-9400-A1F93D77FDE3}" type="datetimeFigureOut">
               <a:rPr lang="en-SE" smtClean="0"/>
-              <a:t>2025-12-08</a:t>
+              <a:t>2025-12-12</a:t>
             </a:fld>
             <a:endParaRPr lang="en-SE"/>
           </a:p>
@@ -2925,7 +2931,7 @@
           <a:p>
             <a:fld id="{23DBF8B2-B501-47AE-9400-A1F93D77FDE3}" type="datetimeFigureOut">
               <a:rPr lang="en-SE" smtClean="0"/>
-              <a:t>2025-12-08</a:t>
+              <a:t>2025-12-12</a:t>
             </a:fld>
             <a:endParaRPr lang="en-SE"/>
           </a:p>
@@ -3342,6 +3348,55 @@
           <a:chExt cx="0" cy="0"/>
         </a:xfrm>
       </p:grpSpPr>
+      <p:sp>
+        <p:nvSpPr>
+          <p:cNvPr id="23" name="Rectangle 22">
+            <a:extLst>
+              <a:ext uri="{FF2B5EF4-FFF2-40B4-BE49-F238E27FC236}">
+                <a16:creationId xmlns:a16="http://schemas.microsoft.com/office/drawing/2014/main" id="{1F3CF8D9-2BD6-CDE8-9038-19F484ED3A7A}"/>
+              </a:ext>
+            </a:extLst>
+          </p:cNvPr>
+          <p:cNvSpPr/>
+          <p:nvPr/>
+        </p:nvSpPr>
+        <p:spPr>
+          <a:xfrm>
+            <a:off x="169682" y="200771"/>
+            <a:ext cx="11491275" cy="6379138"/>
+          </a:xfrm>
+          <a:prstGeom prst="rect">
+            <a:avLst/>
+          </a:prstGeom>
+          <a:solidFill>
+            <a:schemeClr val="bg1"/>
+          </a:solidFill>
+        </p:spPr>
+        <p:style>
+          <a:lnRef idx="2">
+            <a:schemeClr val="accent1">
+              <a:shade val="15000"/>
+            </a:schemeClr>
+          </a:lnRef>
+          <a:fillRef idx="1">
+            <a:schemeClr val="accent1"/>
+          </a:fillRef>
+          <a:effectRef idx="0">
+            <a:schemeClr val="accent1"/>
+          </a:effectRef>
+          <a:fontRef idx="minor">
+            <a:schemeClr val="lt1"/>
+          </a:fontRef>
+        </p:style>
+        <p:txBody>
+          <a:bodyPr rtlCol="0" anchor="ctr"/>
+          <a:lstStyle/>
+          <a:p>
+            <a:pPr algn="ctr"/>
+            <a:endParaRPr lang="en-SE"/>
+          </a:p>
+        </p:txBody>
+      </p:sp>
       <p:pic>
         <p:nvPicPr>
           <p:cNvPr id="5" name="Picture 4" descr="A diagram of a network&#10;&#10;AI-generated content may be incorrect.">
@@ -3950,6 +4005,335 @@
     <p:extLst>
       <p:ext uri="{BB962C8B-B14F-4D97-AF65-F5344CB8AC3E}">
         <p14:creationId xmlns:p14="http://schemas.microsoft.com/office/powerpoint/2010/main" val="1243910450"/>
+      </p:ext>
+    </p:extLst>
+  </p:cSld>
+  <p:clrMapOvr>
+    <a:masterClrMapping/>
+  </p:clrMapOvr>
+</p:sld>
+</file>
+
+<file path=ppt/slides/slide2.xml><?xml version="1.0" encoding="utf-8"?>
+<p:sld xmlns:a="http://schemas.openxmlformats.org/drawingml/2006/main" xmlns:r="http://schemas.openxmlformats.org/officeDocument/2006/relationships" xmlns:p="http://schemas.openxmlformats.org/presentationml/2006/main">
+  <p:cSld>
+    <p:spTree>
+      <p:nvGrpSpPr>
+        <p:cNvPr id="1" name=""/>
+        <p:cNvGrpSpPr/>
+        <p:nvPr/>
+      </p:nvGrpSpPr>
+      <p:grpSpPr>
+        <a:xfrm>
+          <a:off x="0" y="0"/>
+          <a:ext cx="0" cy="0"/>
+          <a:chOff x="0" y="0"/>
+          <a:chExt cx="0" cy="0"/>
+        </a:xfrm>
+      </p:grpSpPr>
+      <p:sp>
+        <p:nvSpPr>
+          <p:cNvPr id="3" name="Rectangle 2">
+            <a:extLst>
+              <a:ext uri="{FF2B5EF4-FFF2-40B4-BE49-F238E27FC236}">
+                <a16:creationId xmlns:a16="http://schemas.microsoft.com/office/drawing/2014/main" id="{00DED49A-90C8-5C1B-E782-CE9BDE3DF27E}"/>
+              </a:ext>
+            </a:extLst>
+          </p:cNvPr>
+          <p:cNvSpPr/>
+          <p:nvPr/>
+        </p:nvSpPr>
+        <p:spPr>
+          <a:xfrm>
+            <a:off x="1304925" y="1743075"/>
+            <a:ext cx="8429625" cy="2971800"/>
+          </a:xfrm>
+          <a:prstGeom prst="rect">
+            <a:avLst/>
+          </a:prstGeom>
+          <a:solidFill>
+            <a:schemeClr val="bg1"/>
+          </a:solidFill>
+        </p:spPr>
+        <p:style>
+          <a:lnRef idx="2">
+            <a:schemeClr val="accent1">
+              <a:shade val="15000"/>
+            </a:schemeClr>
+          </a:lnRef>
+          <a:fillRef idx="1">
+            <a:schemeClr val="accent1"/>
+          </a:fillRef>
+          <a:effectRef idx="0">
+            <a:schemeClr val="accent1"/>
+          </a:effectRef>
+          <a:fontRef idx="minor">
+            <a:schemeClr val="lt1"/>
+          </a:fontRef>
+        </p:style>
+        <p:txBody>
+          <a:bodyPr rtlCol="0" anchor="ctr"/>
+          <a:lstStyle/>
+          <a:p>
+            <a:pPr algn="ctr"/>
+            <a:endParaRPr lang="en-SE"/>
+          </a:p>
+        </p:txBody>
+      </p:sp>
+      <p:sp>
+        <p:nvSpPr>
+          <p:cNvPr id="4" name="Oval 3">
+            <a:extLst>
+              <a:ext uri="{FF2B5EF4-FFF2-40B4-BE49-F238E27FC236}">
+                <a16:creationId xmlns:a16="http://schemas.microsoft.com/office/drawing/2014/main" id="{C8C80CAD-E3AF-052D-E861-E3D8BEE3C12B}"/>
+              </a:ext>
+            </a:extLst>
+          </p:cNvPr>
+          <p:cNvSpPr/>
+          <p:nvPr/>
+        </p:nvSpPr>
+        <p:spPr>
+          <a:xfrm>
+            <a:off x="1482571" y="2055180"/>
+            <a:ext cx="2374777" cy="2401409"/>
+          </a:xfrm>
+          <a:prstGeom prst="ellipse">
+            <a:avLst/>
+          </a:prstGeom>
+          <a:ln w="25400"/>
+        </p:spPr>
+        <p:style>
+          <a:lnRef idx="2">
+            <a:schemeClr val="accent1">
+              <a:shade val="15000"/>
+            </a:schemeClr>
+          </a:lnRef>
+          <a:fillRef idx="1">
+            <a:schemeClr val="accent1"/>
+          </a:fillRef>
+          <a:effectRef idx="0">
+            <a:schemeClr val="accent1"/>
+          </a:effectRef>
+          <a:fontRef idx="minor">
+            <a:schemeClr val="lt1"/>
+          </a:fontRef>
+        </p:style>
+        <p:txBody>
+          <a:bodyPr rtlCol="0" anchor="ctr"/>
+          <a:lstStyle/>
+          <a:p>
+            <a:pPr algn="ctr"/>
+            <a:r>
+              <a:rPr lang="en-US" dirty="0"/>
+              <a:t>Dataset</a:t>
+            </a:r>
+            <a:endParaRPr lang="en-SE" dirty="0"/>
+          </a:p>
+        </p:txBody>
+      </p:sp>
+      <p:sp>
+        <p:nvSpPr>
+          <p:cNvPr id="5" name="Oval 4">
+            <a:extLst>
+              <a:ext uri="{FF2B5EF4-FFF2-40B4-BE49-F238E27FC236}">
+                <a16:creationId xmlns:a16="http://schemas.microsoft.com/office/drawing/2014/main" id="{192E8DB8-170E-0032-1BBC-6964240AAC1C}"/>
+              </a:ext>
+            </a:extLst>
+          </p:cNvPr>
+          <p:cNvSpPr/>
+          <p:nvPr/>
+        </p:nvSpPr>
+        <p:spPr>
+          <a:xfrm>
+            <a:off x="4792462" y="2654424"/>
+            <a:ext cx="1303538" cy="1154096"/>
+          </a:xfrm>
+          <a:prstGeom prst="ellipse">
+            <a:avLst/>
+          </a:prstGeom>
+          <a:solidFill>
+            <a:schemeClr val="accent2"/>
+          </a:solidFill>
+          <a:ln w="25400"/>
+        </p:spPr>
+        <p:style>
+          <a:lnRef idx="2">
+            <a:schemeClr val="accent1">
+              <a:shade val="15000"/>
+            </a:schemeClr>
+          </a:lnRef>
+          <a:fillRef idx="1">
+            <a:schemeClr val="accent1"/>
+          </a:fillRef>
+          <a:effectRef idx="0">
+            <a:schemeClr val="accent1"/>
+          </a:effectRef>
+          <a:fontRef idx="minor">
+            <a:schemeClr val="lt1"/>
+          </a:fontRef>
+        </p:style>
+        <p:txBody>
+          <a:bodyPr rtlCol="0" anchor="ctr"/>
+          <a:lstStyle/>
+          <a:p>
+            <a:pPr algn="ctr"/>
+            <a:r>
+              <a:rPr lang="en-US" sz="1200" dirty="0"/>
+              <a:t>Projection on smaller subspace</a:t>
+            </a:r>
+            <a:endParaRPr lang="en-SE" sz="1200" dirty="0"/>
+          </a:p>
+        </p:txBody>
+      </p:sp>
+      <p:sp>
+        <p:nvSpPr>
+          <p:cNvPr id="6" name="Oval 5">
+            <a:extLst>
+              <a:ext uri="{FF2B5EF4-FFF2-40B4-BE49-F238E27FC236}">
+                <a16:creationId xmlns:a16="http://schemas.microsoft.com/office/drawing/2014/main" id="{A73FAC18-4A67-1ABA-5609-4823FB4AE56C}"/>
+              </a:ext>
+            </a:extLst>
+          </p:cNvPr>
+          <p:cNvSpPr/>
+          <p:nvPr/>
+        </p:nvSpPr>
+        <p:spPr>
+          <a:xfrm>
+            <a:off x="7031114" y="2066277"/>
+            <a:ext cx="2374777" cy="2330388"/>
+          </a:xfrm>
+          <a:prstGeom prst="ellipse">
+            <a:avLst/>
+          </a:prstGeom>
+          <a:ln w="25400"/>
+        </p:spPr>
+        <p:style>
+          <a:lnRef idx="2">
+            <a:schemeClr val="accent1">
+              <a:shade val="15000"/>
+            </a:schemeClr>
+          </a:lnRef>
+          <a:fillRef idx="1">
+            <a:schemeClr val="accent1"/>
+          </a:fillRef>
+          <a:effectRef idx="0">
+            <a:schemeClr val="accent1"/>
+          </a:effectRef>
+          <a:fontRef idx="minor">
+            <a:schemeClr val="lt1"/>
+          </a:fontRef>
+        </p:style>
+        <p:txBody>
+          <a:bodyPr rtlCol="0" anchor="ctr"/>
+          <a:lstStyle/>
+          <a:p>
+            <a:pPr algn="ctr"/>
+            <a:r>
+              <a:rPr lang="en-US" dirty="0"/>
+              <a:t>Reconstructed Dataset</a:t>
+            </a:r>
+            <a:endParaRPr lang="en-SE" dirty="0"/>
+          </a:p>
+        </p:txBody>
+      </p:sp>
+      <p:sp>
+        <p:nvSpPr>
+          <p:cNvPr id="7" name="Arrow: Right 6">
+            <a:extLst>
+              <a:ext uri="{FF2B5EF4-FFF2-40B4-BE49-F238E27FC236}">
+                <a16:creationId xmlns:a16="http://schemas.microsoft.com/office/drawing/2014/main" id="{2C0B8E4C-4785-973D-08B3-EE548F49AB95}"/>
+              </a:ext>
+            </a:extLst>
+          </p:cNvPr>
+          <p:cNvSpPr/>
+          <p:nvPr/>
+        </p:nvSpPr>
+        <p:spPr>
+          <a:xfrm>
+            <a:off x="4043039" y="3033942"/>
+            <a:ext cx="563732" cy="443883"/>
+          </a:xfrm>
+          <a:prstGeom prst="rightArrow">
+            <a:avLst/>
+          </a:prstGeom>
+          <a:ln w="25400"/>
+        </p:spPr>
+        <p:style>
+          <a:lnRef idx="2">
+            <a:schemeClr val="accent1">
+              <a:shade val="15000"/>
+            </a:schemeClr>
+          </a:lnRef>
+          <a:fillRef idx="1">
+            <a:schemeClr val="accent1"/>
+          </a:fillRef>
+          <a:effectRef idx="0">
+            <a:schemeClr val="accent1"/>
+          </a:effectRef>
+          <a:fontRef idx="minor">
+            <a:schemeClr val="lt1"/>
+          </a:fontRef>
+        </p:style>
+        <p:txBody>
+          <a:bodyPr rtlCol="0" anchor="ctr"/>
+          <a:lstStyle/>
+          <a:p>
+            <a:pPr algn="ctr"/>
+            <a:endParaRPr lang="en-SE"/>
+          </a:p>
+        </p:txBody>
+      </p:sp>
+      <p:sp>
+        <p:nvSpPr>
+          <p:cNvPr id="8" name="Arrow: Right 7">
+            <a:extLst>
+              <a:ext uri="{FF2B5EF4-FFF2-40B4-BE49-F238E27FC236}">
+                <a16:creationId xmlns:a16="http://schemas.microsoft.com/office/drawing/2014/main" id="{ACA207C3-37D2-BC6E-3C68-01A6B16828E7}"/>
+              </a:ext>
+            </a:extLst>
+          </p:cNvPr>
+          <p:cNvSpPr/>
+          <p:nvPr/>
+        </p:nvSpPr>
+        <p:spPr>
+          <a:xfrm>
+            <a:off x="6281691" y="3009530"/>
+            <a:ext cx="563732" cy="443883"/>
+          </a:xfrm>
+          <a:prstGeom prst="rightArrow">
+            <a:avLst/>
+          </a:prstGeom>
+          <a:ln w="25400"/>
+        </p:spPr>
+        <p:style>
+          <a:lnRef idx="2">
+            <a:schemeClr val="accent1">
+              <a:shade val="15000"/>
+            </a:schemeClr>
+          </a:lnRef>
+          <a:fillRef idx="1">
+            <a:schemeClr val="accent1"/>
+          </a:fillRef>
+          <a:effectRef idx="0">
+            <a:schemeClr val="accent1"/>
+          </a:effectRef>
+          <a:fontRef idx="minor">
+            <a:schemeClr val="lt1"/>
+          </a:fontRef>
+        </p:style>
+        <p:txBody>
+          <a:bodyPr rtlCol="0" anchor="ctr"/>
+          <a:lstStyle/>
+          <a:p>
+            <a:pPr algn="ctr"/>
+            <a:endParaRPr lang="en-SE"/>
+          </a:p>
+        </p:txBody>
+      </p:sp>
+    </p:spTree>
+    <p:extLst>
+      <p:ext uri="{BB962C8B-B14F-4D97-AF65-F5344CB8AC3E}">
+        <p14:creationId xmlns:p14="http://schemas.microsoft.com/office/powerpoint/2010/main" val="3088627669"/>
       </p:ext>
     </p:extLst>
   </p:cSld>

</xml_diff>